<commit_message>
Juicier coin FX and fully animated shop previews
Earning coins now pops and flashes the HUD counter, floats a '+N coin'
element up from it, rolls the number up tick by tick, and bursts gold
coin particles in-world (recycle, rescue, golden bottle). The shop
replaces static dots with animated previews: outfit discs showing
cap/shirt/pants bands with a shine sweep (premium outfits pulse-glow),
rope bars with gradients and an animated rainbow rope, and live name-tag
previews that render the player's own name in each style's animation
(rainbow spin, sparkle pulse, fire flicker, ocean wave, gold shine,
galaxy shift). Rows lift on hover; equipped rows are highlighted; the
shop balance pops on purchase.

Co-Authored-By: Claude Fable 5 <noreply@anthropic.com>
</commit_message>
<xml_diff>
--- a/Garbage-Grapple-Sustainability.pptx
+++ b/Garbage-Grapple-Sustainability.pptx
@@ -5,17 +5,18 @@
     <p:sldMasterId id="2147483648" r:id="rId1"/>
   </p:sldMasterIdLst>
   <p:sldIdLst>
-    <p:sldId id="256" r:id="rId7"/>
-    <p:sldId id="257" r:id="rId8"/>
-    <p:sldId id="258" r:id="rId9"/>
-    <p:sldId id="259" r:id="rId10"/>
-    <p:sldId id="260" r:id="rId11"/>
-    <p:sldId id="261" r:id="rId12"/>
-    <p:sldId id="262" r:id="rId13"/>
-    <p:sldId id="263" r:id="rId14"/>
-    <p:sldId id="264" r:id="rId15"/>
+    <p:sldId id="256" r:id="rId2"/>
+    <p:sldId id="257" r:id="rId3"/>
+    <p:sldId id="258" r:id="rId4"/>
+    <p:sldId id="259" r:id="rId5"/>
+    <p:sldId id="260" r:id="rId6"/>
+    <p:sldId id="261" r:id="rId7"/>
+    <p:sldId id="262" r:id="rId8"/>
+    <p:sldId id="263" r:id="rId9"/>
+    <p:sldId id="264" r:id="rId10"/>
+    <p:sldId id="265" r:id="rId11"/>
   </p:sldIdLst>
-  <p:sldSz cx="12191695" cy="6858000" type="screen4x3"/>
+  <p:sldSz cx="12192000" cy="6858000"/>
   <p:notesSz cx="6858000" cy="9144000"/>
   <p:defaultTextStyle>
     <a:defPPr>
@@ -112,6 +113,22 @@
       </a:defRPr>
     </a:lvl9pPr>
   </p:defaultTextStyle>
+  <p:extLst>
+    <p:ext uri="{EFAFB233-063F-42B5-8137-9DF3F51BA10A}">
+      <p15:sldGuideLst xmlns:p15="http://schemas.microsoft.com/office/powerpoint/2012/main">
+        <p15:guide id="1" orient="horz" pos="2160">
+          <p15:clr>
+            <a:srgbClr val="A4A3A4"/>
+          </p15:clr>
+        </p15:guide>
+        <p15:guide id="2" pos="2880">
+          <p15:clr>
+            <a:srgbClr val="A4A3A4"/>
+          </p15:clr>
+        </p15:guide>
+      </p15:sldGuideLst>
+    </p:ext>
+  </p:extLst>
 </p:presentation>
 </file>
 
@@ -153,10 +170,9 @@
           <a:lstStyle/>
           <a:p>
             <a:r>
-              <a:rPr lang="en-US" smtClean="0"/>
+              <a:rPr lang="en-US"/>
               <a:t>Click to edit Master title style</a:t>
             </a:r>
-            <a:endParaRPr lang="en-US"/>
           </a:p>
         </p:txBody>
       </p:sp>
@@ -272,10 +288,9 @@
           </a:lstStyle>
           <a:p>
             <a:r>
-              <a:rPr lang="en-US" smtClean="0"/>
+              <a:rPr lang="en-US"/>
               <a:t>Click to edit Master subtitle style</a:t>
             </a:r>
-            <a:endParaRPr lang="en-US"/>
           </a:p>
         </p:txBody>
       </p:sp>
@@ -296,7 +311,7 @@
           <a:p>
             <a:fld id="{5BCAD085-E8A6-8845-BD4E-CB4CCA059FC4}" type="datetimeFigureOut">
               <a:rPr lang="en-US" smtClean="0"/>
-              <a:t>1/27/13</a:t>
+              <a:t>7/27/2026</a:t>
             </a:fld>
             <a:endParaRPr lang="en-US"/>
           </a:p>
@@ -390,10 +405,9 @@
           <a:lstStyle/>
           <a:p>
             <a:r>
-              <a:rPr lang="en-US" smtClean="0"/>
+              <a:rPr lang="en-US"/>
               <a:t>Click to edit Master title style</a:t>
             </a:r>
-            <a:endParaRPr lang="en-US"/>
           </a:p>
         </p:txBody>
       </p:sp>
@@ -414,38 +428,37 @@
           <a:p>
             <a:pPr lvl="0"/>
             <a:r>
-              <a:rPr lang="en-US" smtClean="0"/>
+              <a:rPr lang="en-US"/>
               <a:t>Click to edit Master text styles</a:t>
             </a:r>
           </a:p>
           <a:p>
             <a:pPr lvl="1"/>
             <a:r>
-              <a:rPr lang="en-US" smtClean="0"/>
+              <a:rPr lang="en-US"/>
               <a:t>Second level</a:t>
             </a:r>
           </a:p>
           <a:p>
             <a:pPr lvl="2"/>
             <a:r>
-              <a:rPr lang="en-US" smtClean="0"/>
+              <a:rPr lang="en-US"/>
               <a:t>Third level</a:t>
             </a:r>
           </a:p>
           <a:p>
             <a:pPr lvl="3"/>
             <a:r>
-              <a:rPr lang="en-US" smtClean="0"/>
+              <a:rPr lang="en-US"/>
               <a:t>Fourth level</a:t>
             </a:r>
           </a:p>
           <a:p>
             <a:pPr lvl="4"/>
             <a:r>
-              <a:rPr lang="en-US" smtClean="0"/>
+              <a:rPr lang="en-US"/>
               <a:t>Fifth level</a:t>
             </a:r>
-            <a:endParaRPr lang="en-US"/>
           </a:p>
         </p:txBody>
       </p:sp>
@@ -466,7 +479,7 @@
           <a:p>
             <a:fld id="{5BCAD085-E8A6-8845-BD4E-CB4CCA059FC4}" type="datetimeFigureOut">
               <a:rPr lang="en-US" smtClean="0"/>
-              <a:t>1/27/13</a:t>
+              <a:t>7/27/2026</a:t>
             </a:fld>
             <a:endParaRPr lang="en-US"/>
           </a:p>
@@ -565,10 +578,9 @@
           <a:lstStyle/>
           <a:p>
             <a:r>
-              <a:rPr lang="en-US" smtClean="0"/>
+              <a:rPr lang="en-US"/>
               <a:t>Click to edit Master title style</a:t>
             </a:r>
-            <a:endParaRPr lang="en-US"/>
           </a:p>
         </p:txBody>
       </p:sp>
@@ -594,38 +606,37 @@
           <a:p>
             <a:pPr lvl="0"/>
             <a:r>
-              <a:rPr lang="en-US" smtClean="0"/>
+              <a:rPr lang="en-US"/>
               <a:t>Click to edit Master text styles</a:t>
             </a:r>
           </a:p>
           <a:p>
             <a:pPr lvl="1"/>
             <a:r>
-              <a:rPr lang="en-US" smtClean="0"/>
+              <a:rPr lang="en-US"/>
               <a:t>Second level</a:t>
             </a:r>
           </a:p>
           <a:p>
             <a:pPr lvl="2"/>
             <a:r>
-              <a:rPr lang="en-US" smtClean="0"/>
+              <a:rPr lang="en-US"/>
               <a:t>Third level</a:t>
             </a:r>
           </a:p>
           <a:p>
             <a:pPr lvl="3"/>
             <a:r>
-              <a:rPr lang="en-US" smtClean="0"/>
+              <a:rPr lang="en-US"/>
               <a:t>Fourth level</a:t>
             </a:r>
           </a:p>
           <a:p>
             <a:pPr lvl="4"/>
             <a:r>
-              <a:rPr lang="en-US" smtClean="0"/>
+              <a:rPr lang="en-US"/>
               <a:t>Fifth level</a:t>
             </a:r>
-            <a:endParaRPr lang="en-US"/>
           </a:p>
         </p:txBody>
       </p:sp>
@@ -646,7 +657,7 @@
           <a:p>
             <a:fld id="{5BCAD085-E8A6-8845-BD4E-CB4CCA059FC4}" type="datetimeFigureOut">
               <a:rPr lang="en-US" smtClean="0"/>
-              <a:t>1/27/13</a:t>
+              <a:t>7/27/2026</a:t>
             </a:fld>
             <a:endParaRPr lang="en-US"/>
           </a:p>
@@ -740,10 +751,9 @@
           <a:lstStyle/>
           <a:p>
             <a:r>
-              <a:rPr lang="en-US" smtClean="0"/>
+              <a:rPr lang="en-US"/>
               <a:t>Click to edit Master title style</a:t>
             </a:r>
-            <a:endParaRPr lang="en-US"/>
           </a:p>
         </p:txBody>
       </p:sp>
@@ -764,38 +774,37 @@
           <a:p>
             <a:pPr lvl="0"/>
             <a:r>
-              <a:rPr lang="en-US" smtClean="0"/>
+              <a:rPr lang="en-US"/>
               <a:t>Click to edit Master text styles</a:t>
             </a:r>
           </a:p>
           <a:p>
             <a:pPr lvl="1"/>
             <a:r>
-              <a:rPr lang="en-US" smtClean="0"/>
+              <a:rPr lang="en-US"/>
               <a:t>Second level</a:t>
             </a:r>
           </a:p>
           <a:p>
             <a:pPr lvl="2"/>
             <a:r>
-              <a:rPr lang="en-US" smtClean="0"/>
+              <a:rPr lang="en-US"/>
               <a:t>Third level</a:t>
             </a:r>
           </a:p>
           <a:p>
             <a:pPr lvl="3"/>
             <a:r>
-              <a:rPr lang="en-US" smtClean="0"/>
+              <a:rPr lang="en-US"/>
               <a:t>Fourth level</a:t>
             </a:r>
           </a:p>
           <a:p>
             <a:pPr lvl="4"/>
             <a:r>
-              <a:rPr lang="en-US" smtClean="0"/>
+              <a:rPr lang="en-US"/>
               <a:t>Fifth level</a:t>
             </a:r>
-            <a:endParaRPr lang="en-US"/>
           </a:p>
         </p:txBody>
       </p:sp>
@@ -816,7 +825,7 @@
           <a:p>
             <a:fld id="{5BCAD085-E8A6-8845-BD4E-CB4CCA059FC4}" type="datetimeFigureOut">
               <a:rPr lang="en-US" smtClean="0"/>
-              <a:t>1/27/13</a:t>
+              <a:t>7/27/2026</a:t>
             </a:fld>
             <a:endParaRPr lang="en-US"/>
           </a:p>
@@ -919,10 +928,9 @@
           </a:lstStyle>
           <a:p>
             <a:r>
-              <a:rPr lang="en-US" smtClean="0"/>
+              <a:rPr lang="en-US"/>
               <a:t>Click to edit Master title style</a:t>
             </a:r>
-            <a:endParaRPr lang="en-US"/>
           </a:p>
         </p:txBody>
       </p:sp>
@@ -1039,7 +1047,7 @@
           <a:p>
             <a:pPr lvl="0"/>
             <a:r>
-              <a:rPr lang="en-US" smtClean="0"/>
+              <a:rPr lang="en-US"/>
               <a:t>Click to edit Master text styles</a:t>
             </a:r>
           </a:p>
@@ -1062,7 +1070,7 @@
           <a:p>
             <a:fld id="{5BCAD085-E8A6-8845-BD4E-CB4CCA059FC4}" type="datetimeFigureOut">
               <a:rPr lang="en-US" smtClean="0"/>
-              <a:t>1/27/13</a:t>
+              <a:t>7/27/2026</a:t>
             </a:fld>
             <a:endParaRPr lang="en-US"/>
           </a:p>
@@ -1156,10 +1164,9 @@
           <a:lstStyle/>
           <a:p>
             <a:r>
-              <a:rPr lang="en-US" smtClean="0"/>
+              <a:rPr lang="en-US"/>
               <a:t>Click to edit Master title style</a:t>
             </a:r>
-            <a:endParaRPr lang="en-US"/>
           </a:p>
         </p:txBody>
       </p:sp>
@@ -1213,38 +1220,37 @@
           <a:p>
             <a:pPr lvl="0"/>
             <a:r>
-              <a:rPr lang="en-US" smtClean="0"/>
+              <a:rPr lang="en-US"/>
               <a:t>Click to edit Master text styles</a:t>
             </a:r>
           </a:p>
           <a:p>
             <a:pPr lvl="1"/>
             <a:r>
-              <a:rPr lang="en-US" smtClean="0"/>
+              <a:rPr lang="en-US"/>
               <a:t>Second level</a:t>
             </a:r>
           </a:p>
           <a:p>
             <a:pPr lvl="2"/>
             <a:r>
-              <a:rPr lang="en-US" smtClean="0"/>
+              <a:rPr lang="en-US"/>
               <a:t>Third level</a:t>
             </a:r>
           </a:p>
           <a:p>
             <a:pPr lvl="3"/>
             <a:r>
-              <a:rPr lang="en-US" smtClean="0"/>
+              <a:rPr lang="en-US"/>
               <a:t>Fourth level</a:t>
             </a:r>
           </a:p>
           <a:p>
             <a:pPr lvl="4"/>
             <a:r>
-              <a:rPr lang="en-US" smtClean="0"/>
+              <a:rPr lang="en-US"/>
               <a:t>Fifth level</a:t>
             </a:r>
-            <a:endParaRPr lang="en-US"/>
           </a:p>
         </p:txBody>
       </p:sp>
@@ -1298,38 +1304,37 @@
           <a:p>
             <a:pPr lvl="0"/>
             <a:r>
-              <a:rPr lang="en-US" smtClean="0"/>
+              <a:rPr lang="en-US"/>
               <a:t>Click to edit Master text styles</a:t>
             </a:r>
           </a:p>
           <a:p>
             <a:pPr lvl="1"/>
             <a:r>
-              <a:rPr lang="en-US" smtClean="0"/>
+              <a:rPr lang="en-US"/>
               <a:t>Second level</a:t>
             </a:r>
           </a:p>
           <a:p>
             <a:pPr lvl="2"/>
             <a:r>
-              <a:rPr lang="en-US" smtClean="0"/>
+              <a:rPr lang="en-US"/>
               <a:t>Third level</a:t>
             </a:r>
           </a:p>
           <a:p>
             <a:pPr lvl="3"/>
             <a:r>
-              <a:rPr lang="en-US" smtClean="0"/>
+              <a:rPr lang="en-US"/>
               <a:t>Fourth level</a:t>
             </a:r>
           </a:p>
           <a:p>
             <a:pPr lvl="4"/>
             <a:r>
-              <a:rPr lang="en-US" smtClean="0"/>
+              <a:rPr lang="en-US"/>
               <a:t>Fifth level</a:t>
             </a:r>
-            <a:endParaRPr lang="en-US"/>
           </a:p>
         </p:txBody>
       </p:sp>
@@ -1350,7 +1355,7 @@
           <a:p>
             <a:fld id="{5BCAD085-E8A6-8845-BD4E-CB4CCA059FC4}" type="datetimeFigureOut">
               <a:rPr lang="en-US" smtClean="0"/>
-              <a:t>1/27/13</a:t>
+              <a:t>7/27/2026</a:t>
             </a:fld>
             <a:endParaRPr lang="en-US"/>
           </a:p>
@@ -1448,10 +1453,9 @@
           </a:lstStyle>
           <a:p>
             <a:r>
-              <a:rPr lang="en-US" smtClean="0"/>
+              <a:rPr lang="en-US"/>
               <a:t>Click to edit Master title style</a:t>
             </a:r>
-            <a:endParaRPr lang="en-US"/>
           </a:p>
         </p:txBody>
       </p:sp>
@@ -1514,7 +1518,7 @@
           <a:p>
             <a:pPr lvl="0"/>
             <a:r>
-              <a:rPr lang="en-US" smtClean="0"/>
+              <a:rPr lang="en-US"/>
               <a:t>Click to edit Master text styles</a:t>
             </a:r>
           </a:p>
@@ -1570,38 +1574,37 @@
           <a:p>
             <a:pPr lvl="0"/>
             <a:r>
-              <a:rPr lang="en-US" smtClean="0"/>
+              <a:rPr lang="en-US"/>
               <a:t>Click to edit Master text styles</a:t>
             </a:r>
           </a:p>
           <a:p>
             <a:pPr lvl="1"/>
             <a:r>
-              <a:rPr lang="en-US" smtClean="0"/>
+              <a:rPr lang="en-US"/>
               <a:t>Second level</a:t>
             </a:r>
           </a:p>
           <a:p>
             <a:pPr lvl="2"/>
             <a:r>
-              <a:rPr lang="en-US" smtClean="0"/>
+              <a:rPr lang="en-US"/>
               <a:t>Third level</a:t>
             </a:r>
           </a:p>
           <a:p>
             <a:pPr lvl="3"/>
             <a:r>
-              <a:rPr lang="en-US" smtClean="0"/>
+              <a:rPr lang="en-US"/>
               <a:t>Fourth level</a:t>
             </a:r>
           </a:p>
           <a:p>
             <a:pPr lvl="4"/>
             <a:r>
-              <a:rPr lang="en-US" smtClean="0"/>
+              <a:rPr lang="en-US"/>
               <a:t>Fifth level</a:t>
             </a:r>
-            <a:endParaRPr lang="en-US"/>
           </a:p>
         </p:txBody>
       </p:sp>
@@ -1664,7 +1667,7 @@
           <a:p>
             <a:pPr lvl="0"/>
             <a:r>
-              <a:rPr lang="en-US" smtClean="0"/>
+              <a:rPr lang="en-US"/>
               <a:t>Click to edit Master text styles</a:t>
             </a:r>
           </a:p>
@@ -1720,38 +1723,37 @@
           <a:p>
             <a:pPr lvl="0"/>
             <a:r>
-              <a:rPr lang="en-US" smtClean="0"/>
+              <a:rPr lang="en-US"/>
               <a:t>Click to edit Master text styles</a:t>
             </a:r>
           </a:p>
           <a:p>
             <a:pPr lvl="1"/>
             <a:r>
-              <a:rPr lang="en-US" smtClean="0"/>
+              <a:rPr lang="en-US"/>
               <a:t>Second level</a:t>
             </a:r>
           </a:p>
           <a:p>
             <a:pPr lvl="2"/>
             <a:r>
-              <a:rPr lang="en-US" smtClean="0"/>
+              <a:rPr lang="en-US"/>
               <a:t>Third level</a:t>
             </a:r>
           </a:p>
           <a:p>
             <a:pPr lvl="3"/>
             <a:r>
-              <a:rPr lang="en-US" smtClean="0"/>
+              <a:rPr lang="en-US"/>
               <a:t>Fourth level</a:t>
             </a:r>
           </a:p>
           <a:p>
             <a:pPr lvl="4"/>
             <a:r>
-              <a:rPr lang="en-US" smtClean="0"/>
+              <a:rPr lang="en-US"/>
               <a:t>Fifth level</a:t>
             </a:r>
-            <a:endParaRPr lang="en-US"/>
           </a:p>
         </p:txBody>
       </p:sp>
@@ -1772,7 +1774,7 @@
           <a:p>
             <a:fld id="{5BCAD085-E8A6-8845-BD4E-CB4CCA059FC4}" type="datetimeFigureOut">
               <a:rPr lang="en-US" smtClean="0"/>
-              <a:t>1/27/13</a:t>
+              <a:t>7/27/2026</a:t>
             </a:fld>
             <a:endParaRPr lang="en-US"/>
           </a:p>
@@ -1866,10 +1868,9 @@
           <a:lstStyle/>
           <a:p>
             <a:r>
-              <a:rPr lang="en-US" smtClean="0"/>
+              <a:rPr lang="en-US"/>
               <a:t>Click to edit Master title style</a:t>
             </a:r>
-            <a:endParaRPr lang="en-US"/>
           </a:p>
         </p:txBody>
       </p:sp>
@@ -1890,7 +1891,7 @@
           <a:p>
             <a:fld id="{5BCAD085-E8A6-8845-BD4E-CB4CCA059FC4}" type="datetimeFigureOut">
               <a:rPr lang="en-US" smtClean="0"/>
-              <a:t>1/27/13</a:t>
+              <a:t>7/27/2026</a:t>
             </a:fld>
             <a:endParaRPr lang="en-US"/>
           </a:p>
@@ -1985,7 +1986,7 @@
           <a:p>
             <a:fld id="{5BCAD085-E8A6-8845-BD4E-CB4CCA059FC4}" type="datetimeFigureOut">
               <a:rPr lang="en-US" smtClean="0"/>
-              <a:t>1/27/13</a:t>
+              <a:t>7/27/2026</a:t>
             </a:fld>
             <a:endParaRPr lang="en-US"/>
           </a:p>
@@ -2088,10 +2089,9 @@
           </a:lstStyle>
           <a:p>
             <a:r>
-              <a:rPr lang="en-US" smtClean="0"/>
+              <a:rPr lang="en-US"/>
               <a:t>Click to edit Master title style</a:t>
             </a:r>
-            <a:endParaRPr lang="en-US"/>
           </a:p>
         </p:txBody>
       </p:sp>
@@ -2145,38 +2145,37 @@
           <a:p>
             <a:pPr lvl="0"/>
             <a:r>
-              <a:rPr lang="en-US" smtClean="0"/>
+              <a:rPr lang="en-US"/>
               <a:t>Click to edit Master text styles</a:t>
             </a:r>
           </a:p>
           <a:p>
             <a:pPr lvl="1"/>
             <a:r>
-              <a:rPr lang="en-US" smtClean="0"/>
+              <a:rPr lang="en-US"/>
               <a:t>Second level</a:t>
             </a:r>
           </a:p>
           <a:p>
             <a:pPr lvl="2"/>
             <a:r>
-              <a:rPr lang="en-US" smtClean="0"/>
+              <a:rPr lang="en-US"/>
               <a:t>Third level</a:t>
             </a:r>
           </a:p>
           <a:p>
             <a:pPr lvl="3"/>
             <a:r>
-              <a:rPr lang="en-US" smtClean="0"/>
+              <a:rPr lang="en-US"/>
               <a:t>Fourth level</a:t>
             </a:r>
           </a:p>
           <a:p>
             <a:pPr lvl="4"/>
             <a:r>
-              <a:rPr lang="en-US" smtClean="0"/>
+              <a:rPr lang="en-US"/>
               <a:t>Fifth level</a:t>
             </a:r>
-            <a:endParaRPr lang="en-US"/>
           </a:p>
         </p:txBody>
       </p:sp>
@@ -2239,7 +2238,7 @@
           <a:p>
             <a:pPr lvl="0"/>
             <a:r>
-              <a:rPr lang="en-US" smtClean="0"/>
+              <a:rPr lang="en-US"/>
               <a:t>Click to edit Master text styles</a:t>
             </a:r>
           </a:p>
@@ -2262,7 +2261,7 @@
           <a:p>
             <a:fld id="{5BCAD085-E8A6-8845-BD4E-CB4CCA059FC4}" type="datetimeFigureOut">
               <a:rPr lang="en-US" smtClean="0"/>
-              <a:t>1/27/13</a:t>
+              <a:t>7/27/2026</a:t>
             </a:fld>
             <a:endParaRPr lang="en-US"/>
           </a:p>
@@ -2365,10 +2364,9 @@
           </a:lstStyle>
           <a:p>
             <a:r>
-              <a:rPr lang="en-US" smtClean="0"/>
+              <a:rPr lang="en-US"/>
               <a:t>Click to edit Master title style</a:t>
             </a:r>
-            <a:endParaRPr lang="en-US"/>
           </a:p>
         </p:txBody>
       </p:sp>
@@ -2492,7 +2490,7 @@
           <a:p>
             <a:pPr lvl="0"/>
             <a:r>
-              <a:rPr lang="en-US" smtClean="0"/>
+              <a:rPr lang="en-US"/>
               <a:t>Click to edit Master text styles</a:t>
             </a:r>
           </a:p>
@@ -2515,7 +2513,7 @@
           <a:p>
             <a:fld id="{5BCAD085-E8A6-8845-BD4E-CB4CCA059FC4}" type="datetimeFigureOut">
               <a:rPr lang="en-US" smtClean="0"/>
-              <a:t>1/27/13</a:t>
+              <a:t>7/27/2026</a:t>
             </a:fld>
             <a:endParaRPr lang="en-US"/>
           </a:p>
@@ -2624,10 +2622,9 @@
           <a:lstStyle/>
           <a:p>
             <a:r>
-              <a:rPr lang="en-US" smtClean="0"/>
+              <a:rPr lang="en-US"/>
               <a:t>Click to edit Master title style</a:t>
             </a:r>
-            <a:endParaRPr lang="en-US"/>
           </a:p>
         </p:txBody>
       </p:sp>
@@ -2658,38 +2655,37 @@
           <a:p>
             <a:pPr lvl="0"/>
             <a:r>
-              <a:rPr lang="en-US" smtClean="0"/>
+              <a:rPr lang="en-US"/>
               <a:t>Click to edit Master text styles</a:t>
             </a:r>
           </a:p>
           <a:p>
             <a:pPr lvl="1"/>
             <a:r>
-              <a:rPr lang="en-US" smtClean="0"/>
+              <a:rPr lang="en-US"/>
               <a:t>Second level</a:t>
             </a:r>
           </a:p>
           <a:p>
             <a:pPr lvl="2"/>
             <a:r>
-              <a:rPr lang="en-US" smtClean="0"/>
+              <a:rPr lang="en-US"/>
               <a:t>Third level</a:t>
             </a:r>
           </a:p>
           <a:p>
             <a:pPr lvl="3"/>
             <a:r>
-              <a:rPr lang="en-US" smtClean="0"/>
+              <a:rPr lang="en-US"/>
               <a:t>Fourth level</a:t>
             </a:r>
           </a:p>
           <a:p>
             <a:pPr lvl="4"/>
             <a:r>
-              <a:rPr lang="en-US" smtClean="0"/>
+              <a:rPr lang="en-US"/>
               <a:t>Fifth level</a:t>
             </a:r>
-            <a:endParaRPr lang="en-US"/>
           </a:p>
         </p:txBody>
       </p:sp>
@@ -2728,7 +2724,7 @@
           <a:p>
             <a:fld id="{5BCAD085-E8A6-8845-BD4E-CB4CCA059FC4}" type="datetimeFigureOut">
               <a:rPr lang="en-US" smtClean="0"/>
-              <a:t>1/27/13</a:t>
+              <a:t>7/27/2026</a:t>
             </a:fld>
             <a:endParaRPr lang="en-US"/>
           </a:p>
@@ -3087,7 +3083,7 @@
 </file>
 
 <file path=ppt/slides/slide1.xml><?xml version="1.0" encoding="utf-8"?>
-<p:sld xmlns:a="http://schemas.openxmlformats.org/drawingml/2006/main" xmlns:p="http://schemas.openxmlformats.org/presentationml/2006/main" xmlns:r="http://schemas.openxmlformats.org/officeDocument/2006/relationships">
+<p:sld xmlns:a="http://schemas.openxmlformats.org/drawingml/2006/main" xmlns:r="http://schemas.openxmlformats.org/officeDocument/2006/relationships" xmlns:p="http://schemas.openxmlformats.org/presentationml/2006/main">
   <p:cSld>
     <p:bg>
       <p:bgPr>
@@ -3103,7 +3099,14 @@
         <p:cNvGrpSpPr/>
         <p:nvPr/>
       </p:nvGrpSpPr>
-      <p:grpSpPr/>
+      <p:grpSpPr>
+        <a:xfrm>
+          <a:off x="0" y="0"/>
+          <a:ext cx="0" cy="0"/>
+          <a:chOff x="0" y="0"/>
+          <a:chExt cx="0" cy="0"/>
+        </a:xfrm>
+      </p:grpSpPr>
       <p:sp>
         <p:nvSpPr>
           <p:cNvPr id="2" name="TextBox 1"/>
@@ -3113,7 +3116,7 @@
         <p:spPr>
           <a:xfrm>
             <a:off x="685800" y="1051560"/>
-            <a:ext cx="5669280" cy="3291840"/>
+            <a:ext cx="5669280" cy="3154710"/>
           </a:xfrm>
           <a:prstGeom prst="rect">
             <a:avLst/>
@@ -3121,7 +3124,7 @@
           <a:noFill/>
         </p:spPr>
         <p:txBody>
-          <a:bodyPr wrap="square" lIns="0" rIns="0" tIns="0" bIns="0">
+          <a:bodyPr wrap="square" lIns="0" tIns="0" rIns="0" bIns="0">
             <a:spAutoFit/>
           </a:bodyPr>
           <a:lstStyle/>
@@ -3132,7 +3135,7 @@
               </a:spcAft>
             </a:pPr>
             <a:r>
-              <a:rPr sz="1300" b="1" i="0">
+              <a:rPr sz="1300" b="1" i="0" dirty="0">
                 <a:solidFill>
                   <a:srgbClr val="97BC62"/>
                 </a:solidFill>
@@ -3148,7 +3151,7 @@
               </a:spcAft>
             </a:pPr>
             <a:r>
-              <a:rPr sz="5400" b="1" i="0">
+              <a:rPr sz="5400" b="1" i="0" dirty="0">
                 <a:solidFill>
                   <a:srgbClr val="FFFFFF"/>
                 </a:solidFill>
@@ -3164,7 +3167,7 @@
               </a:spcAft>
             </a:pPr>
             <a:r>
-              <a:rPr sz="5400" b="1" i="0">
+              <a:rPr sz="5400" b="1" i="0" dirty="0">
                 <a:solidFill>
                   <a:srgbClr val="E8B33C"/>
                 </a:solidFill>
@@ -3180,7 +3183,7 @@
               </a:spcAft>
             </a:pPr>
             <a:r>
-              <a:rPr sz="1600" b="0" i="1">
+              <a:rPr sz="1600" b="0" i="1" dirty="0">
                 <a:solidFill>
                   <a:srgbClr val="EFF5E9"/>
                 </a:solidFill>
@@ -3196,7 +3199,7 @@
               </a:spcAft>
             </a:pPr>
             <a:r>
-              <a:rPr sz="1400" b="1" i="0">
+              <a:rPr sz="1400" b="1" i="0" dirty="0">
                 <a:solidFill>
                   <a:srgbClr val="97BC62"/>
                 </a:solidFill>
@@ -3212,13 +3215,49 @@
               </a:spcAft>
             </a:pPr>
             <a:r>
-              <a:rPr sz="1400" b="0" i="0">
+              <a:rPr sz="1400" b="0" i="0" dirty="0">
                 <a:solidFill>
                   <a:srgbClr val="EFF5E9"/>
                 </a:solidFill>
                 <a:latin typeface="Calibri"/>
               </a:rPr>
-              <a:t>By Viyaan  ·  DPSI</a:t>
+              <a:t>By Viaan </a:t>
+            </a:r>
+            <a:r>
+              <a:rPr lang="en-US" sz="1400" b="0" i="0" dirty="0">
+                <a:solidFill>
+                  <a:srgbClr val="EFF5E9"/>
+                </a:solidFill>
+                <a:latin typeface="Calibri"/>
+              </a:rPr>
+              <a:t> and </a:t>
+            </a:r>
+            <a:r>
+              <a:rPr lang="en-US" sz="1400" dirty="0">
+                <a:solidFill>
+                  <a:srgbClr val="EFF5E9"/>
+                </a:solidFill>
+                <a:latin typeface="Calibri"/>
+              </a:rPr>
+              <a:t>M</a:t>
+            </a:r>
+            <a:r>
+              <a:rPr lang="en-US" sz="1400" b="0" i="0" dirty="0">
+                <a:solidFill>
+                  <a:srgbClr val="EFF5E9"/>
+                </a:solidFill>
+                <a:latin typeface="Calibri"/>
+              </a:rPr>
+              <a:t>ihir</a:t>
+            </a:r>
+            <a:r>
+              <a:rPr sz="1400" b="0" i="0" dirty="0">
+                <a:solidFill>
+                  <a:srgbClr val="EFF5E9"/>
+                </a:solidFill>
+                <a:latin typeface="Calibri"/>
+              </a:rPr>
+              <a:t> ·  DPSI</a:t>
             </a:r>
           </a:p>
         </p:txBody>
@@ -3269,7 +3308,7 @@
           <a:noFill/>
         </p:spPr>
         <p:txBody>
-          <a:bodyPr wrap="square" lIns="0" rIns="0" tIns="0" bIns="0">
+          <a:bodyPr wrap="square" lIns="0" tIns="0" rIns="0" bIns="0">
             <a:spAutoFit/>
           </a:bodyPr>
           <a:lstStyle/>
@@ -3308,7 +3347,7 @@
           <a:noFill/>
         </p:spPr>
         <p:txBody>
-          <a:bodyPr wrap="square" lIns="0" rIns="0" tIns="0" bIns="0">
+          <a:bodyPr wrap="square" lIns="0" tIns="0" rIns="0" bIns="0">
             <a:spAutoFit/>
           </a:bodyPr>
           <a:lstStyle/>
@@ -3331,6 +3370,84 @@
         </p:txBody>
       </p:sp>
     </p:spTree>
+  </p:cSld>
+  <p:clrMapOvr>
+    <a:masterClrMapping/>
+  </p:clrMapOvr>
+  <mc:AlternateContent xmlns:mc="http://schemas.openxmlformats.org/markup-compatibility/2006">
+    <mc:Choice xmlns:p15="http://schemas.microsoft.com/office/powerpoint/2012/main" Requires="p15">
+      <p:transition xmlns:p14="http://schemas.microsoft.com/office/powerpoint/2010/main" spd="slow" p14:dur="6000">
+        <p15:prstTrans prst="curtains"/>
+      </p:transition>
+    </mc:Choice>
+    <mc:Fallback>
+      <p:transition spd="slow">
+        <p:fade/>
+      </p:transition>
+    </mc:Fallback>
+  </mc:AlternateContent>
+</p:sld>
+</file>
+
+<file path=ppt/slides/slide10.xml><?xml version="1.0" encoding="utf-8"?>
+<p:sld xmlns:a="http://schemas.openxmlformats.org/drawingml/2006/main" xmlns:r="http://schemas.openxmlformats.org/officeDocument/2006/relationships" xmlns:p="http://schemas.openxmlformats.org/presentationml/2006/main">
+  <p:cSld>
+    <p:spTree>
+      <p:nvGrpSpPr>
+        <p:cNvPr id="1" name=""/>
+        <p:cNvGrpSpPr/>
+        <p:nvPr/>
+      </p:nvGrpSpPr>
+      <p:grpSpPr>
+        <a:xfrm>
+          <a:off x="0" y="0"/>
+          <a:ext cx="0" cy="0"/>
+          <a:chOff x="0" y="0"/>
+          <a:chExt cx="0" cy="0"/>
+        </a:xfrm>
+      </p:grpSpPr>
+      <p:pic>
+        <p:nvPicPr>
+          <p:cNvPr id="3" name="Picture 2">
+            <a:extLst>
+              <a:ext uri="{FF2B5EF4-FFF2-40B4-BE49-F238E27FC236}">
+                <a16:creationId xmlns:a16="http://schemas.microsoft.com/office/drawing/2014/main" id="{2FA2EE56-3ACC-0048-C33B-343DDDDD9B5D}"/>
+              </a:ext>
+            </a:extLst>
+          </p:cNvPr>
+          <p:cNvPicPr>
+            <a:picLocks noChangeAspect="1"/>
+          </p:cNvPicPr>
+          <p:nvPr/>
+        </p:nvPicPr>
+        <p:blipFill>
+          <a:blip r:embed="rId2">
+            <a:extLst>
+              <a:ext uri="{837473B0-CC2E-450A-ABE3-18F120FF3D39}">
+                <a1611:picAttrSrcUrl xmlns:a1611="http://schemas.microsoft.com/office/drawing/2016/11/main" r:id="rId3"/>
+              </a:ext>
+            </a:extLst>
+          </a:blip>
+          <a:stretch>
+            <a:fillRect/>
+          </a:stretch>
+        </p:blipFill>
+        <p:spPr>
+          <a:xfrm>
+            <a:off x="0" y="-1309815"/>
+            <a:ext cx="12192000" cy="8237088"/>
+          </a:xfrm>
+          <a:prstGeom prst="rect">
+            <a:avLst/>
+          </a:prstGeom>
+        </p:spPr>
+      </p:pic>
+    </p:spTree>
+    <p:extLst>
+      <p:ext uri="{BB962C8B-B14F-4D97-AF65-F5344CB8AC3E}">
+        <p14:creationId xmlns:p14="http://schemas.microsoft.com/office/powerpoint/2010/main" val="1433343800"/>
+      </p:ext>
+    </p:extLst>
   </p:cSld>
   <p:clrMapOvr>
     <a:masterClrMapping/>
@@ -3339,7 +3456,7 @@
 </file>
 
 <file path=ppt/slides/slide2.xml><?xml version="1.0" encoding="utf-8"?>
-<p:sld xmlns:a="http://schemas.openxmlformats.org/drawingml/2006/main" xmlns:p="http://schemas.openxmlformats.org/presentationml/2006/main" xmlns:r="http://schemas.openxmlformats.org/officeDocument/2006/relationships">
+<p:sld xmlns:a="http://schemas.openxmlformats.org/drawingml/2006/main" xmlns:r="http://schemas.openxmlformats.org/officeDocument/2006/relationships" xmlns:p="http://schemas.openxmlformats.org/presentationml/2006/main">
   <p:cSld>
     <p:bg>
       <p:bgPr>
@@ -3355,7 +3472,14 @@
         <p:cNvGrpSpPr/>
         <p:nvPr/>
       </p:nvGrpSpPr>
-      <p:grpSpPr/>
+      <p:grpSpPr>
+        <a:xfrm>
+          <a:off x="0" y="0"/>
+          <a:ext cx="0" cy="0"/>
+          <a:chOff x="0" y="0"/>
+          <a:chExt cx="0" cy="0"/>
+        </a:xfrm>
+      </p:grpSpPr>
       <p:sp>
         <p:nvSpPr>
           <p:cNvPr id="2" name="TextBox 1"/>
@@ -3373,7 +3497,7 @@
           <a:noFill/>
         </p:spPr>
         <p:txBody>
-          <a:bodyPr wrap="square" lIns="0" rIns="0" tIns="0" bIns="0">
+          <a:bodyPr wrap="square" lIns="0" tIns="0" rIns="0" bIns="0">
             <a:spAutoFit/>
           </a:bodyPr>
           <a:lstStyle/>
@@ -3412,7 +3536,7 @@
           <a:noFill/>
         </p:spPr>
         <p:txBody>
-          <a:bodyPr wrap="square" lIns="0" rIns="0" tIns="0" bIns="0">
+          <a:bodyPr wrap="square" lIns="0" tIns="0" rIns="0" bIns="0">
             <a:spAutoFit/>
           </a:bodyPr>
           <a:lstStyle/>
@@ -3467,7 +3591,7 @@
           <a:noFill/>
         </p:spPr>
         <p:txBody>
-          <a:bodyPr wrap="square" lIns="0" rIns="0" tIns="0" bIns="0">
+          <a:bodyPr wrap="square" lIns="0" tIns="0" rIns="0" bIns="0">
             <a:spAutoFit/>
           </a:bodyPr>
           <a:lstStyle/>
@@ -3522,7 +3646,7 @@
           <a:noFill/>
         </p:spPr>
         <p:txBody>
-          <a:bodyPr wrap="square" lIns="0" rIns="0" tIns="0" bIns="0">
+          <a:bodyPr wrap="square" lIns="0" tIns="0" rIns="0" bIns="0">
             <a:spAutoFit/>
           </a:bodyPr>
           <a:lstStyle/>
@@ -3606,7 +3730,7 @@
           <a:noFill/>
         </p:spPr>
         <p:txBody>
-          <a:bodyPr wrap="square" lIns="0" rIns="0" tIns="0" bIns="0">
+          <a:bodyPr wrap="square" lIns="0" tIns="0" rIns="0" bIns="0">
             <a:spAutoFit/>
           </a:bodyPr>
           <a:lstStyle/>
@@ -3645,7 +3769,7 @@
           <a:noFill/>
         </p:spPr>
         <p:txBody>
-          <a:bodyPr wrap="square" lIns="0" rIns="0" tIns="0" bIns="0">
+          <a:bodyPr wrap="square" lIns="0" tIns="0" rIns="0" bIns="0">
             <a:spAutoFit/>
           </a:bodyPr>
           <a:lstStyle/>
@@ -3672,11 +3796,14 @@
   <p:clrMapOvr>
     <a:masterClrMapping/>
   </p:clrMapOvr>
+  <p:transition spd="slow">
+    <p:randomBar dir="vert"/>
+  </p:transition>
 </p:sld>
 </file>
 
 <file path=ppt/slides/slide3.xml><?xml version="1.0" encoding="utf-8"?>
-<p:sld xmlns:a="http://schemas.openxmlformats.org/drawingml/2006/main" xmlns:p="http://schemas.openxmlformats.org/presentationml/2006/main" xmlns:r="http://schemas.openxmlformats.org/officeDocument/2006/relationships">
+<p:sld xmlns:a="http://schemas.openxmlformats.org/drawingml/2006/main" xmlns:r="http://schemas.openxmlformats.org/officeDocument/2006/relationships" xmlns:p="http://schemas.openxmlformats.org/presentationml/2006/main">
   <p:cSld>
     <p:bg>
       <p:bgPr>
@@ -3692,7 +3819,14 @@
         <p:cNvGrpSpPr/>
         <p:nvPr/>
       </p:nvGrpSpPr>
-      <p:grpSpPr/>
+      <p:grpSpPr>
+        <a:xfrm>
+          <a:off x="0" y="0"/>
+          <a:ext cx="0" cy="0"/>
+          <a:chOff x="0" y="0"/>
+          <a:chExt cx="0" cy="0"/>
+        </a:xfrm>
+      </p:grpSpPr>
       <p:sp>
         <p:nvSpPr>
           <p:cNvPr id="2" name="TextBox 1"/>
@@ -3710,7 +3844,7 @@
           <a:noFill/>
         </p:spPr>
         <p:txBody>
-          <a:bodyPr wrap="square" lIns="0" rIns="0" tIns="0" bIns="0">
+          <a:bodyPr wrap="square" lIns="0" tIns="0" rIns="0" bIns="0">
             <a:spAutoFit/>
           </a:bodyPr>
           <a:lstStyle/>
@@ -3749,7 +3883,7 @@
           <a:noFill/>
         </p:spPr>
         <p:txBody>
-          <a:bodyPr wrap="square" lIns="0" rIns="0" tIns="0" bIns="0">
+          <a:bodyPr wrap="square" lIns="0" tIns="0" rIns="0" bIns="0">
             <a:spAutoFit/>
           </a:bodyPr>
           <a:lstStyle/>
@@ -3868,7 +4002,7 @@
           <a:noFill/>
         </p:spPr>
         <p:txBody>
-          <a:bodyPr wrap="square" lIns="0" rIns="0" tIns="0" bIns="0">
+          <a:bodyPr wrap="square" lIns="0" tIns="0" rIns="0" bIns="0">
             <a:spAutoFit/>
           </a:bodyPr>
           <a:lstStyle/>
@@ -3936,7 +4070,7 @@
           <a:noFill/>
         </p:spPr>
         <p:txBody>
-          <a:bodyPr wrap="square" lIns="0" rIns="0" tIns="0" bIns="0">
+          <a:bodyPr wrap="square" lIns="0" tIns="0" rIns="0" bIns="0">
             <a:spAutoFit/>
           </a:bodyPr>
           <a:lstStyle/>
@@ -3963,11 +4097,23 @@
   <p:clrMapOvr>
     <a:masterClrMapping/>
   </p:clrMapOvr>
+  <mc:AlternateContent xmlns:mc="http://schemas.openxmlformats.org/markup-compatibility/2006">
+    <mc:Choice xmlns:p15="http://schemas.microsoft.com/office/powerpoint/2012/main" Requires="p15">
+      <p:transition xmlns:p14="http://schemas.microsoft.com/office/powerpoint/2010/main" spd="slow" p14:dur="2000">
+        <p15:prstTrans prst="prestige"/>
+      </p:transition>
+    </mc:Choice>
+    <mc:Fallback>
+      <p:transition spd="slow">
+        <p:fade/>
+      </p:transition>
+    </mc:Fallback>
+  </mc:AlternateContent>
 </p:sld>
 </file>
 
 <file path=ppt/slides/slide4.xml><?xml version="1.0" encoding="utf-8"?>
-<p:sld xmlns:a="http://schemas.openxmlformats.org/drawingml/2006/main" xmlns:p="http://schemas.openxmlformats.org/presentationml/2006/main" xmlns:r="http://schemas.openxmlformats.org/officeDocument/2006/relationships">
+<p:sld xmlns:a="http://schemas.openxmlformats.org/drawingml/2006/main" xmlns:r="http://schemas.openxmlformats.org/officeDocument/2006/relationships" xmlns:p="http://schemas.openxmlformats.org/presentationml/2006/main">
   <p:cSld>
     <p:bg>
       <p:bgPr>
@@ -3983,7 +4129,14 @@
         <p:cNvGrpSpPr/>
         <p:nvPr/>
       </p:nvGrpSpPr>
-      <p:grpSpPr/>
+      <p:grpSpPr>
+        <a:xfrm>
+          <a:off x="0" y="0"/>
+          <a:ext cx="0" cy="0"/>
+          <a:chOff x="0" y="0"/>
+          <a:chExt cx="0" cy="0"/>
+        </a:xfrm>
+      </p:grpSpPr>
       <p:sp>
         <p:nvSpPr>
           <p:cNvPr id="2" name="TextBox 1"/>
@@ -4001,7 +4154,7 @@
           <a:noFill/>
         </p:spPr>
         <p:txBody>
-          <a:bodyPr wrap="square" lIns="0" rIns="0" tIns="0" bIns="0">
+          <a:bodyPr wrap="square" lIns="0" tIns="0" rIns="0" bIns="0">
             <a:spAutoFit/>
           </a:bodyPr>
           <a:lstStyle/>
@@ -4118,7 +4271,7 @@
           </a:fontRef>
         </p:style>
         <p:txBody>
-          <a:bodyPr rtlCol="0" anchor="ctr" wrap="square" lIns="109728" rIns="109728" tIns="36576" bIns="36576"/>
+          <a:bodyPr wrap="square" lIns="109728" tIns="36576" rIns="109728" bIns="36576" rtlCol="0" anchor="ctr"/>
           <a:lstStyle/>
           <a:p>
             <a:pPr algn="l"/>
@@ -4171,7 +4324,7 @@
           </a:fontRef>
         </p:style>
         <p:txBody>
-          <a:bodyPr rtlCol="0" anchor="ctr" wrap="square" lIns="109728" rIns="109728" tIns="36576" bIns="36576"/>
+          <a:bodyPr wrap="square" lIns="109728" tIns="36576" rIns="109728" bIns="36576" rtlCol="0" anchor="ctr"/>
           <a:lstStyle/>
           <a:p>
             <a:pPr algn="l"/>
@@ -4204,7 +4357,7 @@
           <a:noFill/>
         </p:spPr>
         <p:txBody>
-          <a:bodyPr wrap="square" lIns="0" rIns="0" tIns="0" bIns="0">
+          <a:bodyPr wrap="square" lIns="0" tIns="0" rIns="0" bIns="0">
             <a:spAutoFit/>
           </a:bodyPr>
           <a:lstStyle/>
@@ -4243,7 +4396,7 @@
           <a:noFill/>
         </p:spPr>
         <p:txBody>
-          <a:bodyPr wrap="square" lIns="0" rIns="0" tIns="0" bIns="0">
+          <a:bodyPr wrap="square" lIns="0" tIns="0" rIns="0" bIns="0">
             <a:spAutoFit/>
           </a:bodyPr>
           <a:lstStyle/>
@@ -4282,7 +4435,7 @@
           <a:noFill/>
         </p:spPr>
         <p:txBody>
-          <a:bodyPr wrap="square" lIns="0" rIns="0" tIns="0" bIns="0">
+          <a:bodyPr wrap="square" lIns="0" tIns="0" rIns="0" bIns="0">
             <a:spAutoFit/>
           </a:bodyPr>
           <a:lstStyle/>
@@ -4309,11 +4462,23 @@
   <p:clrMapOvr>
     <a:masterClrMapping/>
   </p:clrMapOvr>
+  <mc:AlternateContent xmlns:mc="http://schemas.openxmlformats.org/markup-compatibility/2006">
+    <mc:Choice xmlns:p15="http://schemas.microsoft.com/office/powerpoint/2012/main" Requires="p15">
+      <p:transition xmlns:p14="http://schemas.microsoft.com/office/powerpoint/2010/main" spd="slow" p14:dur="2000">
+        <p15:prstTrans prst="wind"/>
+      </p:transition>
+    </mc:Choice>
+    <mc:Fallback>
+      <p:transition spd="slow">
+        <p:fade/>
+      </p:transition>
+    </mc:Fallback>
+  </mc:AlternateContent>
 </p:sld>
 </file>
 
 <file path=ppt/slides/slide5.xml><?xml version="1.0" encoding="utf-8"?>
-<p:sld xmlns:a="http://schemas.openxmlformats.org/drawingml/2006/main" xmlns:p="http://schemas.openxmlformats.org/presentationml/2006/main" xmlns:r="http://schemas.openxmlformats.org/officeDocument/2006/relationships">
+<p:sld xmlns:a="http://schemas.openxmlformats.org/drawingml/2006/main" xmlns:r="http://schemas.openxmlformats.org/officeDocument/2006/relationships" xmlns:p="http://schemas.openxmlformats.org/presentationml/2006/main">
   <p:cSld>
     <p:bg>
       <p:bgPr>
@@ -4329,7 +4494,14 @@
         <p:cNvGrpSpPr/>
         <p:nvPr/>
       </p:nvGrpSpPr>
-      <p:grpSpPr/>
+      <p:grpSpPr>
+        <a:xfrm>
+          <a:off x="0" y="0"/>
+          <a:ext cx="0" cy="0"/>
+          <a:chOff x="0" y="0"/>
+          <a:chExt cx="0" cy="0"/>
+        </a:xfrm>
+      </p:grpSpPr>
       <p:sp>
         <p:nvSpPr>
           <p:cNvPr id="2" name="TextBox 1"/>
@@ -4347,7 +4519,7 @@
           <a:noFill/>
         </p:spPr>
         <p:txBody>
-          <a:bodyPr wrap="square" lIns="0" rIns="0" tIns="0" bIns="0">
+          <a:bodyPr wrap="square" lIns="0" tIns="0" rIns="0" bIns="0">
             <a:spAutoFit/>
           </a:bodyPr>
           <a:lstStyle/>
@@ -4386,7 +4558,7 @@
           <a:noFill/>
         </p:spPr>
         <p:txBody>
-          <a:bodyPr wrap="square" lIns="0" rIns="0" tIns="0" bIns="0">
+          <a:bodyPr wrap="square" lIns="0" tIns="0" rIns="0" bIns="0">
             <a:spAutoFit/>
           </a:bodyPr>
           <a:lstStyle/>
@@ -4445,19 +4617,11 @@
           </a:fontRef>
         </p:style>
         <p:txBody>
-          <a:bodyPr rtlCol="0" anchor="ctr" wrap="square" lIns="109728" rIns="109728" tIns="36576" bIns="36576"/>
+          <a:bodyPr wrap="square" lIns="109728" tIns="36576" rIns="109728" bIns="36576" rtlCol="0" anchor="ctr"/>
           <a:lstStyle/>
           <a:p>
             <a:pPr algn="l"/>
-            <a:r>
-              <a:rPr sz="1400" b="1">
-                <a:solidFill>
-                  <a:srgbClr val="FFFFFF"/>
-                </a:solidFill>
-                <a:latin typeface="Calibri"/>
-              </a:rPr>
-              <a:t/>
-            </a:r>
+            <a:endParaRPr/>
           </a:p>
         </p:txBody>
       </p:sp>
@@ -4478,7 +4642,7 @@
           <a:noFill/>
         </p:spPr>
         <p:txBody>
-          <a:bodyPr wrap="square" lIns="0" rIns="0" tIns="0" bIns="0">
+          <a:bodyPr wrap="square" lIns="0" tIns="0" rIns="0" bIns="0">
             <a:spAutoFit/>
           </a:bodyPr>
           <a:lstStyle/>
@@ -4537,19 +4701,11 @@
           </a:fontRef>
         </p:style>
         <p:txBody>
-          <a:bodyPr rtlCol="0" anchor="ctr" wrap="square" lIns="109728" rIns="109728" tIns="36576" bIns="36576"/>
+          <a:bodyPr wrap="square" lIns="109728" tIns="36576" rIns="109728" bIns="36576" rtlCol="0" anchor="ctr"/>
           <a:lstStyle/>
           <a:p>
             <a:pPr algn="l"/>
-            <a:r>
-              <a:rPr sz="1400" b="1">
-                <a:solidFill>
-                  <a:srgbClr val="FFFFFF"/>
-                </a:solidFill>
-                <a:latin typeface="Calibri"/>
-              </a:rPr>
-              <a:t/>
-            </a:r>
+            <a:endParaRPr/>
           </a:p>
         </p:txBody>
       </p:sp>
@@ -4570,7 +4726,7 @@
           <a:noFill/>
         </p:spPr>
         <p:txBody>
-          <a:bodyPr wrap="square" lIns="0" rIns="0" tIns="0" bIns="0">
+          <a:bodyPr wrap="square" lIns="0" tIns="0" rIns="0" bIns="0">
             <a:spAutoFit/>
           </a:bodyPr>
           <a:lstStyle/>
@@ -4629,19 +4785,11 @@
           </a:fontRef>
         </p:style>
         <p:txBody>
-          <a:bodyPr rtlCol="0" anchor="ctr" wrap="square" lIns="109728" rIns="109728" tIns="36576" bIns="36576"/>
+          <a:bodyPr wrap="square" lIns="109728" tIns="36576" rIns="109728" bIns="36576" rtlCol="0" anchor="ctr"/>
           <a:lstStyle/>
           <a:p>
             <a:pPr algn="l"/>
-            <a:r>
-              <a:rPr sz="1400" b="1">
-                <a:solidFill>
-                  <a:srgbClr val="FFFFFF"/>
-                </a:solidFill>
-                <a:latin typeface="Calibri"/>
-              </a:rPr>
-              <a:t/>
-            </a:r>
+            <a:endParaRPr/>
           </a:p>
         </p:txBody>
       </p:sp>
@@ -4662,7 +4810,7 @@
           <a:noFill/>
         </p:spPr>
         <p:txBody>
-          <a:bodyPr wrap="square" lIns="0" rIns="0" tIns="0" bIns="0">
+          <a:bodyPr wrap="square" lIns="0" tIns="0" rIns="0" bIns="0">
             <a:spAutoFit/>
           </a:bodyPr>
           <a:lstStyle/>
@@ -4721,19 +4869,11 @@
           </a:fontRef>
         </p:style>
         <p:txBody>
-          <a:bodyPr rtlCol="0" anchor="ctr" wrap="square" lIns="109728" rIns="109728" tIns="36576" bIns="36576"/>
+          <a:bodyPr wrap="square" lIns="109728" tIns="36576" rIns="109728" bIns="36576" rtlCol="0" anchor="ctr"/>
           <a:lstStyle/>
           <a:p>
             <a:pPr algn="l"/>
-            <a:r>
-              <a:rPr sz="1400" b="1">
-                <a:solidFill>
-                  <a:srgbClr val="FFFFFF"/>
-                </a:solidFill>
-                <a:latin typeface="Calibri"/>
-              </a:rPr>
-              <a:t/>
-            </a:r>
+            <a:endParaRPr/>
           </a:p>
         </p:txBody>
       </p:sp>
@@ -4754,7 +4894,7 @@
           <a:noFill/>
         </p:spPr>
         <p:txBody>
-          <a:bodyPr wrap="square" lIns="0" rIns="0" tIns="0" bIns="0">
+          <a:bodyPr wrap="square" lIns="0" tIns="0" rIns="0" bIns="0">
             <a:spAutoFit/>
           </a:bodyPr>
           <a:lstStyle/>
@@ -4813,19 +4953,11 @@
           </a:fontRef>
         </p:style>
         <p:txBody>
-          <a:bodyPr rtlCol="0" anchor="ctr" wrap="square" lIns="109728" rIns="109728" tIns="36576" bIns="36576"/>
+          <a:bodyPr wrap="square" lIns="109728" tIns="36576" rIns="109728" bIns="36576" rtlCol="0" anchor="ctr"/>
           <a:lstStyle/>
           <a:p>
             <a:pPr algn="l"/>
-            <a:r>
-              <a:rPr sz="1400" b="1">
-                <a:solidFill>
-                  <a:srgbClr val="FFFFFF"/>
-                </a:solidFill>
-                <a:latin typeface="Calibri"/>
-              </a:rPr>
-              <a:t/>
-            </a:r>
+            <a:endParaRPr/>
           </a:p>
         </p:txBody>
       </p:sp>
@@ -4846,7 +4978,7 @@
           <a:noFill/>
         </p:spPr>
         <p:txBody>
-          <a:bodyPr wrap="square" lIns="0" rIns="0" tIns="0" bIns="0">
+          <a:bodyPr wrap="square" lIns="0" tIns="0" rIns="0" bIns="0">
             <a:spAutoFit/>
           </a:bodyPr>
           <a:lstStyle/>
@@ -4905,19 +5037,11 @@
           </a:fontRef>
         </p:style>
         <p:txBody>
-          <a:bodyPr rtlCol="0" anchor="ctr" wrap="square" lIns="109728" rIns="109728" tIns="36576" bIns="36576"/>
+          <a:bodyPr wrap="square" lIns="109728" tIns="36576" rIns="109728" bIns="36576" rtlCol="0" anchor="ctr"/>
           <a:lstStyle/>
           <a:p>
             <a:pPr algn="l"/>
-            <a:r>
-              <a:rPr sz="1400" b="1">
-                <a:solidFill>
-                  <a:srgbClr val="FFFFFF"/>
-                </a:solidFill>
-                <a:latin typeface="Calibri"/>
-              </a:rPr>
-              <a:t/>
-            </a:r>
+            <a:endParaRPr/>
           </a:p>
         </p:txBody>
       </p:sp>
@@ -4938,7 +5062,7 @@
           <a:noFill/>
         </p:spPr>
         <p:txBody>
-          <a:bodyPr wrap="square" lIns="0" rIns="0" tIns="0" bIns="0">
+          <a:bodyPr wrap="square" lIns="0" tIns="0" rIns="0" bIns="0">
             <a:spAutoFit/>
           </a:bodyPr>
           <a:lstStyle/>
@@ -5006,7 +5130,7 @@
           <a:noFill/>
         </p:spPr>
         <p:txBody>
-          <a:bodyPr wrap="square" lIns="0" rIns="0" tIns="0" bIns="0">
+          <a:bodyPr wrap="square" lIns="0" tIns="0" rIns="0" bIns="0">
             <a:spAutoFit/>
           </a:bodyPr>
           <a:lstStyle/>
@@ -5045,7 +5169,7 @@
           <a:noFill/>
         </p:spPr>
         <p:txBody>
-          <a:bodyPr wrap="square" lIns="0" rIns="0" tIns="0" bIns="0">
+          <a:bodyPr wrap="square" lIns="0" tIns="0" rIns="0" bIns="0">
             <a:spAutoFit/>
           </a:bodyPr>
           <a:lstStyle/>
@@ -5072,11 +5196,23 @@
   <p:clrMapOvr>
     <a:masterClrMapping/>
   </p:clrMapOvr>
+  <mc:AlternateContent xmlns:mc="http://schemas.openxmlformats.org/markup-compatibility/2006">
+    <mc:Choice xmlns:p15="http://schemas.microsoft.com/office/powerpoint/2012/main" Requires="p15">
+      <p:transition xmlns:p14="http://schemas.microsoft.com/office/powerpoint/2010/main" spd="slow" p14:dur="2000">
+        <p15:prstTrans prst="fallOver"/>
+      </p:transition>
+    </mc:Choice>
+    <mc:Fallback>
+      <p:transition spd="slow">
+        <p:fade/>
+      </p:transition>
+    </mc:Fallback>
+  </mc:AlternateContent>
 </p:sld>
 </file>
 
 <file path=ppt/slides/slide6.xml><?xml version="1.0" encoding="utf-8"?>
-<p:sld xmlns:a="http://schemas.openxmlformats.org/drawingml/2006/main" xmlns:p="http://schemas.openxmlformats.org/presentationml/2006/main" xmlns:r="http://schemas.openxmlformats.org/officeDocument/2006/relationships">
+<p:sld xmlns:a="http://schemas.openxmlformats.org/drawingml/2006/main" xmlns:r="http://schemas.openxmlformats.org/officeDocument/2006/relationships" xmlns:p="http://schemas.openxmlformats.org/presentationml/2006/main">
   <p:cSld>
     <p:bg>
       <p:bgPr>
@@ -5092,7 +5228,14 @@
         <p:cNvGrpSpPr/>
         <p:nvPr/>
       </p:nvGrpSpPr>
-      <p:grpSpPr/>
+      <p:grpSpPr>
+        <a:xfrm>
+          <a:off x="0" y="0"/>
+          <a:ext cx="0" cy="0"/>
+          <a:chOff x="0" y="0"/>
+          <a:chExt cx="0" cy="0"/>
+        </a:xfrm>
+      </p:grpSpPr>
       <p:sp>
         <p:nvSpPr>
           <p:cNvPr id="2" name="TextBox 1"/>
@@ -5110,7 +5253,7 @@
           <a:noFill/>
         </p:spPr>
         <p:txBody>
-          <a:bodyPr wrap="square" lIns="0" rIns="0" tIns="0" bIns="0">
+          <a:bodyPr wrap="square" lIns="0" tIns="0" rIns="0" bIns="0">
             <a:spAutoFit/>
           </a:bodyPr>
           <a:lstStyle/>
@@ -5149,7 +5292,7 @@
           <a:noFill/>
         </p:spPr>
         <p:txBody>
-          <a:bodyPr wrap="square" lIns="0" rIns="0" tIns="0" bIns="0">
+          <a:bodyPr wrap="square" lIns="0" tIns="0" rIns="0" bIns="0">
             <a:spAutoFit/>
           </a:bodyPr>
           <a:lstStyle/>
@@ -5281,7 +5424,7 @@
           <a:noFill/>
         </p:spPr>
         <p:txBody>
-          <a:bodyPr wrap="square" lIns="0" rIns="0" tIns="0" bIns="0">
+          <a:bodyPr wrap="square" lIns="0" tIns="0" rIns="0" bIns="0">
             <a:spAutoFit/>
           </a:bodyPr>
           <a:lstStyle/>
@@ -5308,11 +5451,23 @@
   <p:clrMapOvr>
     <a:masterClrMapping/>
   </p:clrMapOvr>
+  <mc:AlternateContent xmlns:mc="http://schemas.openxmlformats.org/markup-compatibility/2006">
+    <mc:Choice xmlns:p14="http://schemas.microsoft.com/office/powerpoint/2010/main" Requires="p14">
+      <p:transition spd="slow" p14:dur="1600">
+        <p14:prism isInverted="1"/>
+      </p:transition>
+    </mc:Choice>
+    <mc:Fallback>
+      <p:transition spd="slow">
+        <p:fade/>
+      </p:transition>
+    </mc:Fallback>
+  </mc:AlternateContent>
 </p:sld>
 </file>
 
 <file path=ppt/slides/slide7.xml><?xml version="1.0" encoding="utf-8"?>
-<p:sld xmlns:a="http://schemas.openxmlformats.org/drawingml/2006/main" xmlns:p="http://schemas.openxmlformats.org/presentationml/2006/main" xmlns:r="http://schemas.openxmlformats.org/officeDocument/2006/relationships">
+<p:sld xmlns:a="http://schemas.openxmlformats.org/drawingml/2006/main" xmlns:r="http://schemas.openxmlformats.org/officeDocument/2006/relationships" xmlns:p="http://schemas.openxmlformats.org/presentationml/2006/main">
   <p:cSld>
     <p:bg>
       <p:bgPr>
@@ -5328,7 +5483,14 @@
         <p:cNvGrpSpPr/>
         <p:nvPr/>
       </p:nvGrpSpPr>
-      <p:grpSpPr/>
+      <p:grpSpPr>
+        <a:xfrm>
+          <a:off x="0" y="0"/>
+          <a:ext cx="0" cy="0"/>
+          <a:chOff x="0" y="0"/>
+          <a:chExt cx="0" cy="0"/>
+        </a:xfrm>
+      </p:grpSpPr>
       <p:sp>
         <p:nvSpPr>
           <p:cNvPr id="2" name="TextBox 1"/>
@@ -5346,7 +5508,7 @@
           <a:noFill/>
         </p:spPr>
         <p:txBody>
-          <a:bodyPr wrap="square" lIns="0" rIns="0" tIns="0" bIns="0">
+          <a:bodyPr wrap="square" lIns="0" tIns="0" rIns="0" bIns="0">
             <a:spAutoFit/>
           </a:bodyPr>
           <a:lstStyle/>
@@ -5385,7 +5547,7 @@
           <a:noFill/>
         </p:spPr>
         <p:txBody>
-          <a:bodyPr wrap="square" lIns="0" rIns="0" tIns="0" bIns="0">
+          <a:bodyPr wrap="square" lIns="0" tIns="0" rIns="0" bIns="0">
             <a:spAutoFit/>
           </a:bodyPr>
           <a:lstStyle/>
@@ -5446,7 +5608,7 @@
           </a:fontRef>
         </p:style>
         <p:txBody>
-          <a:bodyPr rtlCol="0" anchor="ctr" wrap="square" lIns="137160" rIns="137160"/>
+          <a:bodyPr wrap="square" lIns="137160" rIns="137160" rtlCol="0" anchor="ctr"/>
           <a:lstStyle/>
           <a:p>
             <a:pPr algn="ctr"/>
@@ -5501,7 +5663,7 @@
           </a:fontRef>
         </p:style>
         <p:txBody>
-          <a:bodyPr rtlCol="0" anchor="ctr" wrap="square" lIns="137160" rIns="137160"/>
+          <a:bodyPr wrap="square" lIns="137160" rIns="137160" rtlCol="0" anchor="ctr"/>
           <a:lstStyle/>
           <a:p>
             <a:pPr algn="ctr"/>
@@ -5556,7 +5718,7 @@
           </a:fontRef>
         </p:style>
         <p:txBody>
-          <a:bodyPr rtlCol="0" anchor="ctr" wrap="square" lIns="137160" rIns="137160"/>
+          <a:bodyPr wrap="square" lIns="137160" rIns="137160" rtlCol="0" anchor="ctr"/>
           <a:lstStyle/>
           <a:p>
             <a:pPr algn="ctr"/>
@@ -5589,7 +5751,7 @@
           <a:noFill/>
         </p:spPr>
         <p:txBody>
-          <a:bodyPr wrap="square" lIns="0" rIns="0" tIns="0" bIns="0">
+          <a:bodyPr wrap="square" lIns="0" tIns="0" rIns="0" bIns="0">
             <a:spAutoFit/>
           </a:bodyPr>
           <a:lstStyle/>
@@ -5648,7 +5810,7 @@
           </a:fontRef>
         </p:style>
         <p:txBody>
-          <a:bodyPr rtlCol="0" anchor="ctr" wrap="square" lIns="109728" rIns="109728" tIns="36576" bIns="36576"/>
+          <a:bodyPr wrap="square" lIns="109728" tIns="36576" rIns="109728" bIns="36576" rtlCol="0" anchor="ctr"/>
           <a:lstStyle/>
           <a:p>
             <a:pPr algn="l"/>
@@ -5681,7 +5843,7 @@
           <a:noFill/>
         </p:spPr>
         <p:txBody>
-          <a:bodyPr wrap="square" lIns="0" rIns="0" tIns="0" bIns="0">
+          <a:bodyPr wrap="square" lIns="0" tIns="0" rIns="0" bIns="0">
             <a:spAutoFit/>
           </a:bodyPr>
           <a:lstStyle/>
@@ -5740,7 +5902,7 @@
           </a:fontRef>
         </p:style>
         <p:txBody>
-          <a:bodyPr rtlCol="0" anchor="ctr" wrap="square" lIns="109728" rIns="109728" tIns="36576" bIns="36576"/>
+          <a:bodyPr wrap="square" lIns="109728" tIns="36576" rIns="109728" bIns="36576" rtlCol="0" anchor="ctr"/>
           <a:lstStyle/>
           <a:p>
             <a:pPr algn="l"/>
@@ -5773,7 +5935,7 @@
           <a:noFill/>
         </p:spPr>
         <p:txBody>
-          <a:bodyPr wrap="square" lIns="0" rIns="0" tIns="0" bIns="0">
+          <a:bodyPr wrap="square" lIns="0" tIns="0" rIns="0" bIns="0">
             <a:spAutoFit/>
           </a:bodyPr>
           <a:lstStyle/>
@@ -5832,7 +5994,7 @@
           </a:fontRef>
         </p:style>
         <p:txBody>
-          <a:bodyPr rtlCol="0" anchor="ctr" wrap="square" lIns="109728" rIns="109728" tIns="36576" bIns="36576"/>
+          <a:bodyPr wrap="square" lIns="109728" tIns="36576" rIns="109728" bIns="36576" rtlCol="0" anchor="ctr"/>
           <a:lstStyle/>
           <a:p>
             <a:pPr algn="l"/>
@@ -5865,7 +6027,7 @@
           <a:noFill/>
         </p:spPr>
         <p:txBody>
-          <a:bodyPr wrap="square" lIns="0" rIns="0" tIns="0" bIns="0">
+          <a:bodyPr wrap="square" lIns="0" tIns="0" rIns="0" bIns="0">
             <a:spAutoFit/>
           </a:bodyPr>
           <a:lstStyle/>
@@ -5924,7 +6086,7 @@
           </a:fontRef>
         </p:style>
         <p:txBody>
-          <a:bodyPr rtlCol="0" anchor="ctr" wrap="square" lIns="109728" rIns="109728" tIns="36576" bIns="36576"/>
+          <a:bodyPr wrap="square" lIns="109728" tIns="36576" rIns="109728" bIns="36576" rtlCol="0" anchor="ctr"/>
           <a:lstStyle/>
           <a:p>
             <a:pPr algn="l"/>
@@ -5957,7 +6119,7 @@
           <a:noFill/>
         </p:spPr>
         <p:txBody>
-          <a:bodyPr wrap="square" lIns="0" rIns="0" tIns="0" bIns="0">
+          <a:bodyPr wrap="square" lIns="0" tIns="0" rIns="0" bIns="0">
             <a:spAutoFit/>
           </a:bodyPr>
           <a:lstStyle/>
@@ -6016,7 +6178,7 @@
           </a:fontRef>
         </p:style>
         <p:txBody>
-          <a:bodyPr rtlCol="0" anchor="ctr" wrap="square" lIns="109728" rIns="109728" tIns="36576" bIns="36576"/>
+          <a:bodyPr wrap="square" lIns="109728" tIns="36576" rIns="109728" bIns="36576" rtlCol="0" anchor="ctr"/>
           <a:lstStyle/>
           <a:p>
             <a:pPr algn="l"/>
@@ -6049,7 +6211,7 @@
           <a:noFill/>
         </p:spPr>
         <p:txBody>
-          <a:bodyPr wrap="square" lIns="0" rIns="0" tIns="0" bIns="0">
+          <a:bodyPr wrap="square" lIns="0" tIns="0" rIns="0" bIns="0">
             <a:spAutoFit/>
           </a:bodyPr>
           <a:lstStyle/>
@@ -6088,7 +6250,7 @@
           <a:noFill/>
         </p:spPr>
         <p:txBody>
-          <a:bodyPr wrap="square" lIns="0" rIns="0" tIns="0" bIns="0">
+          <a:bodyPr wrap="square" lIns="0" tIns="0" rIns="0" bIns="0">
             <a:spAutoFit/>
           </a:bodyPr>
           <a:lstStyle/>
@@ -6115,11 +6277,23 @@
   <p:clrMapOvr>
     <a:masterClrMapping/>
   </p:clrMapOvr>
+  <mc:AlternateContent xmlns:mc="http://schemas.openxmlformats.org/markup-compatibility/2006">
+    <mc:Choice xmlns:p14="http://schemas.microsoft.com/office/powerpoint/2010/main" Requires="p14">
+      <p:transition spd="slow" p14:dur="4000">
+        <p14:vortex dir="r"/>
+      </p:transition>
+    </mc:Choice>
+    <mc:Fallback>
+      <p:transition spd="slow">
+        <p:fade/>
+      </p:transition>
+    </mc:Fallback>
+  </mc:AlternateContent>
 </p:sld>
 </file>
 
 <file path=ppt/slides/slide8.xml><?xml version="1.0" encoding="utf-8"?>
-<p:sld xmlns:a="http://schemas.openxmlformats.org/drawingml/2006/main" xmlns:p="http://schemas.openxmlformats.org/presentationml/2006/main" xmlns:r="http://schemas.openxmlformats.org/officeDocument/2006/relationships">
+<p:sld xmlns:a="http://schemas.openxmlformats.org/drawingml/2006/main" xmlns:r="http://schemas.openxmlformats.org/officeDocument/2006/relationships" xmlns:p="http://schemas.openxmlformats.org/presentationml/2006/main">
   <p:cSld>
     <p:bg>
       <p:bgPr>
@@ -6135,7 +6309,14 @@
         <p:cNvGrpSpPr/>
         <p:nvPr/>
       </p:nvGrpSpPr>
-      <p:grpSpPr/>
+      <p:grpSpPr>
+        <a:xfrm>
+          <a:off x="0" y="0"/>
+          <a:ext cx="0" cy="0"/>
+          <a:chOff x="0" y="0"/>
+          <a:chExt cx="0" cy="0"/>
+        </a:xfrm>
+      </p:grpSpPr>
       <p:sp>
         <p:nvSpPr>
           <p:cNvPr id="2" name="TextBox 1"/>
@@ -6153,7 +6334,7 @@
           <a:noFill/>
         </p:spPr>
         <p:txBody>
-          <a:bodyPr wrap="square" lIns="0" rIns="0" tIns="0" bIns="0">
+          <a:bodyPr wrap="square" lIns="0" tIns="0" rIns="0" bIns="0">
             <a:spAutoFit/>
           </a:bodyPr>
           <a:lstStyle/>
@@ -6214,7 +6395,7 @@
           </a:fontRef>
         </p:style>
         <p:txBody>
-          <a:bodyPr rtlCol="0" anchor="ctr" wrap="square" lIns="201168" rIns="201168" tIns="146304"/>
+          <a:bodyPr wrap="square" lIns="201168" tIns="146304" rIns="201168" rtlCol="0" anchor="ctr"/>
           <a:lstStyle/>
           <a:p>
             <a:pPr algn="ctr"/>
@@ -6285,7 +6466,7 @@
           </a:fontRef>
         </p:style>
         <p:txBody>
-          <a:bodyPr rtlCol="0" anchor="ctr" wrap="square" lIns="201168" rIns="201168" tIns="146304"/>
+          <a:bodyPr wrap="square" lIns="201168" tIns="146304" rIns="201168" rtlCol="0" anchor="ctr"/>
           <a:lstStyle/>
           <a:p>
             <a:pPr algn="ctr"/>
@@ -6356,7 +6537,7 @@
           </a:fontRef>
         </p:style>
         <p:txBody>
-          <a:bodyPr rtlCol="0" anchor="ctr" wrap="square" lIns="201168" rIns="201168" tIns="146304"/>
+          <a:bodyPr wrap="square" lIns="201168" tIns="146304" rIns="201168" rtlCol="0" anchor="ctr"/>
           <a:lstStyle/>
           <a:p>
             <a:pPr algn="ctr"/>
@@ -6427,7 +6608,7 @@
           </a:fontRef>
         </p:style>
         <p:txBody>
-          <a:bodyPr rtlCol="0" anchor="ctr" wrap="square" lIns="201168" rIns="201168" tIns="146304"/>
+          <a:bodyPr wrap="square" lIns="201168" tIns="146304" rIns="201168" rtlCol="0" anchor="ctr"/>
           <a:lstStyle/>
           <a:p>
             <a:pPr algn="ctr"/>
@@ -6476,7 +6657,7 @@
           <a:noFill/>
         </p:spPr>
         <p:txBody>
-          <a:bodyPr wrap="square" lIns="0" rIns="0" tIns="0" bIns="0">
+          <a:bodyPr wrap="square" lIns="0" tIns="0" rIns="0" bIns="0">
             <a:spAutoFit/>
           </a:bodyPr>
           <a:lstStyle/>
@@ -6503,11 +6684,23 @@
   <p:clrMapOvr>
     <a:masterClrMapping/>
   </p:clrMapOvr>
+  <mc:AlternateContent xmlns:mc="http://schemas.openxmlformats.org/markup-compatibility/2006">
+    <mc:Choice xmlns:p15="http://schemas.microsoft.com/office/powerpoint/2012/main" Requires="p15">
+      <p:transition xmlns:p14="http://schemas.microsoft.com/office/powerpoint/2010/main" spd="slow" p14:dur="3250">
+        <p15:prstTrans prst="origami"/>
+      </p:transition>
+    </mc:Choice>
+    <mc:Fallback>
+      <p:transition spd="slow">
+        <p:fade/>
+      </p:transition>
+    </mc:Fallback>
+  </mc:AlternateContent>
 </p:sld>
 </file>
 
 <file path=ppt/slides/slide9.xml><?xml version="1.0" encoding="utf-8"?>
-<p:sld xmlns:a="http://schemas.openxmlformats.org/drawingml/2006/main" xmlns:p="http://schemas.openxmlformats.org/presentationml/2006/main" xmlns:r="http://schemas.openxmlformats.org/officeDocument/2006/relationships">
+<p:sld xmlns:a="http://schemas.openxmlformats.org/drawingml/2006/main" xmlns:r="http://schemas.openxmlformats.org/officeDocument/2006/relationships" xmlns:p="http://schemas.openxmlformats.org/presentationml/2006/main">
   <p:cSld>
     <p:bg>
       <p:bgPr>
@@ -6523,7 +6716,14 @@
         <p:cNvGrpSpPr/>
         <p:nvPr/>
       </p:nvGrpSpPr>
-      <p:grpSpPr/>
+      <p:grpSpPr>
+        <a:xfrm>
+          <a:off x="0" y="0"/>
+          <a:ext cx="0" cy="0"/>
+          <a:chOff x="0" y="0"/>
+          <a:chExt cx="0" cy="0"/>
+        </a:xfrm>
+      </p:grpSpPr>
       <p:sp>
         <p:nvSpPr>
           <p:cNvPr id="2" name="TextBox 1"/>
@@ -6541,7 +6741,7 @@
           <a:noFill/>
         </p:spPr>
         <p:txBody>
-          <a:bodyPr wrap="square" lIns="0" rIns="0" tIns="0" bIns="0">
+          <a:bodyPr wrap="square" lIns="0" tIns="0" rIns="0" bIns="0">
             <a:spAutoFit/>
           </a:bodyPr>
           <a:lstStyle/>
@@ -6604,7 +6804,7 @@
         <p:spPr>
           <a:xfrm>
             <a:off x="1097280" y="4206240"/>
-            <a:ext cx="9966960" cy="1463040"/>
+            <a:ext cx="9966960" cy="995144"/>
           </a:xfrm>
           <a:prstGeom prst="rect">
             <a:avLst/>
@@ -6612,7 +6812,7 @@
           <a:noFill/>
         </p:spPr>
         <p:txBody>
-          <a:bodyPr wrap="square" lIns="0" rIns="0" tIns="0" bIns="0">
+          <a:bodyPr wrap="square" lIns="0" tIns="0" rIns="0" bIns="0">
             <a:spAutoFit/>
           </a:bodyPr>
           <a:lstStyle/>
@@ -6623,7 +6823,7 @@
               </a:spcAft>
             </a:pPr>
             <a:r>
-              <a:rPr sz="1700" b="0" i="0">
+              <a:rPr sz="1700" b="0" i="0" dirty="0">
                 <a:solidFill>
                   <a:srgbClr val="EFF5E9"/>
                 </a:solidFill>
@@ -6639,29 +6839,13 @@
               </a:spcAft>
             </a:pPr>
             <a:r>
-              <a:rPr sz="1700" b="0" i="0">
+              <a:rPr sz="1700" b="0" i="0" dirty="0">
                 <a:solidFill>
                   <a:srgbClr val="EFF5E9"/>
                 </a:solidFill>
                 <a:latin typeface="Calibri"/>
               </a:rPr>
               <a:t>and every player leaves knowing the world is worth saving.</a:t>
-            </a:r>
-          </a:p>
-          <a:p>
-            <a:pPr algn="ctr">
-              <a:spcAft>
-                <a:spcPts val="200"/>
-              </a:spcAft>
-            </a:pPr>
-            <a:r>
-              <a:rPr sz="1400" b="1" i="0">
-                <a:solidFill>
-                  <a:srgbClr val="97BC62"/>
-                </a:solidFill>
-                <a:latin typeface="Calibri"/>
-              </a:rPr>
-              <a:t>Play it in your browser:  github.com/3753viaan/garbage-grapple</a:t>
             </a:r>
           </a:p>
           <a:p>
@@ -6671,13 +6855,31 @@
               </a:spcAft>
             </a:pPr>
             <a:r>
-              <a:rPr sz="1400" b="0" i="0">
+              <a:rPr sz="1400" b="0" i="0" dirty="0">
                 <a:solidFill>
                   <a:srgbClr val="EFF5E9"/>
                 </a:solidFill>
                 <a:latin typeface="Calibri"/>
               </a:rPr>
-              <a:t>Thank you!  —  Viyaan · DPSI</a:t>
+              <a:t>Thank you! —  Viaan </a:t>
+            </a:r>
+            <a:r>
+              <a:rPr lang="en-US" sz="1400" b="0" i="0" dirty="0">
+                <a:solidFill>
+                  <a:srgbClr val="EFF5E9"/>
+                </a:solidFill>
+                <a:latin typeface="Calibri"/>
+              </a:rPr>
+              <a:t> and Mihir</a:t>
+            </a:r>
+            <a:r>
+              <a:rPr sz="1400" b="0" i="0" dirty="0">
+                <a:solidFill>
+                  <a:srgbClr val="EFF5E9"/>
+                </a:solidFill>
+                <a:latin typeface="Calibri"/>
+              </a:rPr>
+              <a:t>· DPSI</a:t>
             </a:r>
           </a:p>
         </p:txBody>
@@ -6687,6 +6889,18 @@
   <p:clrMapOvr>
     <a:masterClrMapping/>
   </p:clrMapOvr>
+  <mc:AlternateContent xmlns:mc="http://schemas.openxmlformats.org/markup-compatibility/2006">
+    <mc:Choice xmlns:p15="http://schemas.microsoft.com/office/powerpoint/2012/main" Requires="p15">
+      <p:transition xmlns:p14="http://schemas.microsoft.com/office/powerpoint/2010/main" spd="slow" p14:dur="6000">
+        <p15:prstTrans prst="curtains"/>
+      </p:transition>
+    </mc:Choice>
+    <mc:Fallback>
+      <p:transition spd="slow">
+        <p:fade/>
+      </p:transition>
+    </mc:Fallback>
+  </mc:AlternateContent>
 </p:sld>
 </file>
 

</xml_diff>